<commit_message>
Added HLD and Twine scenario images
</commit_message>
<xml_diff>
--- a/Poster/CSC SDC Poster.pptx
+++ b/Poster/CSC SDC Poster.pptx
@@ -104,6 +104,22 @@
       </a:defRPr>
     </a:lvl9pPr>
   </p:defaultTextStyle>
+  <p:extLst>
+    <p:ext uri="{EFAFB233-063F-42B5-8137-9DF3F51BA10A}">
+      <p15:sldGuideLst xmlns:p15="http://schemas.microsoft.com/office/powerpoint/2012/main">
+        <p15:guide id="1" orient="horz" pos="8640" userDrawn="1">
+          <p15:clr>
+            <a:srgbClr val="A4A3A4"/>
+          </p15:clr>
+        </p15:guide>
+        <p15:guide id="2" pos="11520" userDrawn="1">
+          <p15:clr>
+            <a:srgbClr val="A4A3A4"/>
+          </p15:clr>
+        </p15:guide>
+      </p15:sldGuideLst>
+    </p:ext>
+  </p:extLst>
 </p:presentation>
 </file>
 
@@ -238,7 +254,7 @@
           <a:p>
             <a:fld id="{FE9B830F-8D59-4B23-9C61-1E12B66C3D45}" type="datetimeFigureOut">
               <a:rPr lang="en-US" smtClean="0"/>
-              <a:t>3/25/2026</a:t>
+              <a:t>3/26/2026</a:t>
             </a:fld>
             <a:endParaRPr lang="en-US"/>
           </a:p>
@@ -408,7 +424,7 @@
           <a:p>
             <a:fld id="{FE9B830F-8D59-4B23-9C61-1E12B66C3D45}" type="datetimeFigureOut">
               <a:rPr lang="en-US" smtClean="0"/>
-              <a:t>3/25/2026</a:t>
+              <a:t>3/26/2026</a:t>
             </a:fld>
             <a:endParaRPr lang="en-US"/>
           </a:p>
@@ -588,7 +604,7 @@
           <a:p>
             <a:fld id="{FE9B830F-8D59-4B23-9C61-1E12B66C3D45}" type="datetimeFigureOut">
               <a:rPr lang="en-US" smtClean="0"/>
-              <a:t>3/25/2026</a:t>
+              <a:t>3/26/2026</a:t>
             </a:fld>
             <a:endParaRPr lang="en-US"/>
           </a:p>
@@ -758,7 +774,7 @@
           <a:p>
             <a:fld id="{FE9B830F-8D59-4B23-9C61-1E12B66C3D45}" type="datetimeFigureOut">
               <a:rPr lang="en-US" smtClean="0"/>
-              <a:t>3/25/2026</a:t>
+              <a:t>3/26/2026</a:t>
             </a:fld>
             <a:endParaRPr lang="en-US"/>
           </a:p>
@@ -1004,7 +1020,7 @@
           <a:p>
             <a:fld id="{FE9B830F-8D59-4B23-9C61-1E12B66C3D45}" type="datetimeFigureOut">
               <a:rPr lang="en-US" smtClean="0"/>
-              <a:t>3/25/2026</a:t>
+              <a:t>3/26/2026</a:t>
             </a:fld>
             <a:endParaRPr lang="en-US"/>
           </a:p>
@@ -1236,7 +1252,7 @@
           <a:p>
             <a:fld id="{FE9B830F-8D59-4B23-9C61-1E12B66C3D45}" type="datetimeFigureOut">
               <a:rPr lang="en-US" smtClean="0"/>
-              <a:t>3/25/2026</a:t>
+              <a:t>3/26/2026</a:t>
             </a:fld>
             <a:endParaRPr lang="en-US"/>
           </a:p>
@@ -1603,7 +1619,7 @@
           <a:p>
             <a:fld id="{FE9B830F-8D59-4B23-9C61-1E12B66C3D45}" type="datetimeFigureOut">
               <a:rPr lang="en-US" smtClean="0"/>
-              <a:t>3/25/2026</a:t>
+              <a:t>3/26/2026</a:t>
             </a:fld>
             <a:endParaRPr lang="en-US"/>
           </a:p>
@@ -1721,7 +1737,7 @@
           <a:p>
             <a:fld id="{FE9B830F-8D59-4B23-9C61-1E12B66C3D45}" type="datetimeFigureOut">
               <a:rPr lang="en-US" smtClean="0"/>
-              <a:t>3/25/2026</a:t>
+              <a:t>3/26/2026</a:t>
             </a:fld>
             <a:endParaRPr lang="en-US"/>
           </a:p>
@@ -1816,7 +1832,7 @@
           <a:p>
             <a:fld id="{FE9B830F-8D59-4B23-9C61-1E12B66C3D45}" type="datetimeFigureOut">
               <a:rPr lang="en-US" smtClean="0"/>
-              <a:t>3/25/2026</a:t>
+              <a:t>3/26/2026</a:t>
             </a:fld>
             <a:endParaRPr lang="en-US"/>
           </a:p>
@@ -2093,7 +2109,7 @@
           <a:p>
             <a:fld id="{FE9B830F-8D59-4B23-9C61-1E12B66C3D45}" type="datetimeFigureOut">
               <a:rPr lang="en-US" smtClean="0"/>
-              <a:t>3/25/2026</a:t>
+              <a:t>3/26/2026</a:t>
             </a:fld>
             <a:endParaRPr lang="en-US"/>
           </a:p>
@@ -2350,7 +2366,7 @@
           <a:p>
             <a:fld id="{FE9B830F-8D59-4B23-9C61-1E12B66C3D45}" type="datetimeFigureOut">
               <a:rPr lang="en-US" smtClean="0"/>
-              <a:t>3/25/2026</a:t>
+              <a:t>3/26/2026</a:t>
             </a:fld>
             <a:endParaRPr lang="en-US"/>
           </a:p>
@@ -2563,7 +2579,7 @@
           <a:p>
             <a:fld id="{FE9B830F-8D59-4B23-9C61-1E12B66C3D45}" type="datetimeFigureOut">
               <a:rPr lang="en-US" smtClean="0"/>
-              <a:t>3/25/2026</a:t>
+              <a:t>3/26/2026</a:t>
             </a:fld>
             <a:endParaRPr lang="en-US"/>
           </a:p>
@@ -2986,18 +3002,18 @@
         </p:nvSpPr>
         <p:spPr>
           <a:xfrm>
-            <a:off x="10172700" y="23812"/>
+            <a:off x="10172700" y="0"/>
             <a:ext cx="16230600" cy="2114552"/>
           </a:xfrm>
         </p:spPr>
         <p:txBody>
           <a:bodyPr>
-            <a:normAutofit/>
+            <a:normAutofit fontScale="90000"/>
           </a:bodyPr>
           <a:lstStyle/>
           <a:p>
             <a:r>
-              <a:rPr lang="en-US" sz="12000" dirty="0"/>
+              <a:rPr lang="en-US" sz="12000" b="1" dirty="0"/>
               <a:t>The Nutrition Adventures</a:t>
             </a:r>
           </a:p>
@@ -3031,8 +3047,8 @@
         </p:blipFill>
         <p:spPr>
           <a:xfrm>
-            <a:off x="338137" y="442912"/>
-            <a:ext cx="6599477" cy="1081088"/>
+            <a:off x="338137" y="540544"/>
+            <a:ext cx="9110663" cy="1492456"/>
           </a:xfrm>
           <a:prstGeom prst="rect">
             <a:avLst/>
@@ -3041,26 +3057,402 @@
       </p:pic>
       <p:sp>
         <p:nvSpPr>
-          <p:cNvPr id="7" name="Subtitle 6">
+          <p:cNvPr id="3" name="Title 1">
             <a:extLst>
               <a:ext uri="{FF2B5EF4-FFF2-40B4-BE49-F238E27FC236}">
-                <a16:creationId xmlns:a16="http://schemas.microsoft.com/office/drawing/2014/main" id="{28AA49ED-EE6C-AB91-D6F9-26B82E573A9A}"/>
+                <a16:creationId xmlns:a16="http://schemas.microsoft.com/office/drawing/2014/main" id="{5BC47AF0-1970-3A10-DEAF-3DE790815B08}"/>
               </a:ext>
             </a:extLst>
           </p:cNvPr>
-          <p:cNvSpPr>
-            <a:spLocks noGrp="1"/>
-          </p:cNvSpPr>
-          <p:nvPr>
-            <p:ph type="subTitle" idx="1"/>
-          </p:nvPr>
-        </p:nvSpPr>
-        <p:spPr/>
-        <p:txBody>
-          <a:bodyPr/>
-          <a:lstStyle/>
-          <a:p>
-            <a:endParaRPr lang="en-US"/>
+          <p:cNvSpPr txBox="1">
+            <a:spLocks/>
+          </p:cNvSpPr>
+          <p:nvPr/>
+        </p:nvSpPr>
+        <p:spPr>
+          <a:xfrm>
+            <a:off x="10991850" y="2114552"/>
+            <a:ext cx="14592300" cy="1733548"/>
+          </a:xfrm>
+          <a:prstGeom prst="rect">
+            <a:avLst/>
+          </a:prstGeom>
+        </p:spPr>
+        <p:txBody>
+          <a:bodyPr vert="horz" lIns="91440" tIns="45720" rIns="91440" bIns="45720" rtlCol="0" anchor="b">
+            <a:normAutofit fontScale="82500" lnSpcReduction="20000"/>
+          </a:bodyPr>
+          <a:lstStyle>
+            <a:lvl1pPr algn="ctr" defTabSz="3657600" rtl="0" eaLnBrk="1" latinLnBrk="0" hangingPunct="1">
+              <a:lnSpc>
+                <a:spcPct val="90000"/>
+              </a:lnSpc>
+              <a:spcBef>
+                <a:spcPct val="0"/>
+              </a:spcBef>
+              <a:buNone/>
+              <a:defRPr sz="24000" kern="1200">
+                <a:solidFill>
+                  <a:schemeClr val="tx1"/>
+                </a:solidFill>
+                <a:latin typeface="+mj-lt"/>
+                <a:ea typeface="+mj-ea"/>
+                <a:cs typeface="+mj-cs"/>
+              </a:defRPr>
+            </a:lvl1pPr>
+          </a:lstStyle>
+          <a:p>
+            <a:pPr>
+              <a:lnSpc>
+                <a:spcPct val="120000"/>
+              </a:lnSpc>
+            </a:pPr>
+            <a:r>
+              <a:rPr lang="en-US" sz="6000" b="1" dirty="0"/>
+              <a:t>Moe Ko, Juni Qureshi, </a:t>
+            </a:r>
+            <a:r>
+              <a:rPr lang="en-US" sz="6000" b="1" dirty="0" err="1"/>
+              <a:t>Snehanshu</a:t>
+            </a:r>
+            <a:r>
+              <a:rPr lang="en-US" sz="6000" b="1" dirty="0"/>
+              <a:t> Samanta, </a:t>
+            </a:r>
+          </a:p>
+          <a:p>
+            <a:pPr>
+              <a:lnSpc>
+                <a:spcPct val="120000"/>
+              </a:lnSpc>
+            </a:pPr>
+            <a:r>
+              <a:rPr lang="en-US" sz="6000" b="1" dirty="0"/>
+              <a:t>Matthew </a:t>
+            </a:r>
+            <a:r>
+              <a:rPr lang="en-US" sz="6000" b="1" dirty="0" err="1"/>
+              <a:t>Shooman</a:t>
+            </a:r>
+            <a:r>
+              <a:rPr lang="en-US" sz="6000" b="1" dirty="0"/>
+              <a:t>, Alican Sumer</a:t>
+            </a:r>
+          </a:p>
+        </p:txBody>
+      </p:sp>
+      <p:sp>
+        <p:nvSpPr>
+          <p:cNvPr id="4" name="TextBox 3">
+            <a:extLst>
+              <a:ext uri="{FF2B5EF4-FFF2-40B4-BE49-F238E27FC236}">
+                <a16:creationId xmlns:a16="http://schemas.microsoft.com/office/drawing/2014/main" id="{9CD411BE-932F-EE06-DF72-52D5D8F637F2}"/>
+              </a:ext>
+            </a:extLst>
+          </p:cNvPr>
+          <p:cNvSpPr txBox="1"/>
+          <p:nvPr/>
+        </p:nvSpPr>
+        <p:spPr>
+          <a:xfrm>
+            <a:off x="26750963" y="540544"/>
+            <a:ext cx="9486900" cy="1015663"/>
+          </a:xfrm>
+          <a:prstGeom prst="rect">
+            <a:avLst/>
+          </a:prstGeom>
+          <a:noFill/>
+        </p:spPr>
+        <p:txBody>
+          <a:bodyPr wrap="square" rtlCol="0">
+            <a:spAutoFit/>
+          </a:bodyPr>
+          <a:lstStyle/>
+          <a:p>
+            <a:r>
+              <a:rPr lang="en-US" sz="6000" dirty="0"/>
+              <a:t>[INSERT SPONSOR LOGO]</a:t>
+            </a:r>
+          </a:p>
+        </p:txBody>
+      </p:sp>
+      <p:sp>
+        <p:nvSpPr>
+          <p:cNvPr id="6" name="TextBox 5">
+            <a:extLst>
+              <a:ext uri="{FF2B5EF4-FFF2-40B4-BE49-F238E27FC236}">
+                <a16:creationId xmlns:a16="http://schemas.microsoft.com/office/drawing/2014/main" id="{32C3BA45-15FF-D3C7-97B6-91F77915A785}"/>
+              </a:ext>
+            </a:extLst>
+          </p:cNvPr>
+          <p:cNvSpPr txBox="1"/>
+          <p:nvPr/>
+        </p:nvSpPr>
+        <p:spPr>
+          <a:xfrm>
+            <a:off x="800100" y="4572000"/>
+            <a:ext cx="7043851" cy="1077218"/>
+          </a:xfrm>
+          <a:prstGeom prst="rect">
+            <a:avLst/>
+          </a:prstGeom>
+          <a:noFill/>
+        </p:spPr>
+        <p:txBody>
+          <a:bodyPr wrap="none" rtlCol="0">
+            <a:spAutoFit/>
+          </a:bodyPr>
+          <a:lstStyle/>
+          <a:p>
+            <a:r>
+              <a:rPr lang="en-US" sz="6400" dirty="0"/>
+              <a:t>Problem Statement</a:t>
+            </a:r>
+          </a:p>
+        </p:txBody>
+      </p:sp>
+      <p:sp>
+        <p:nvSpPr>
+          <p:cNvPr id="8" name="TextBox 7">
+            <a:extLst>
+              <a:ext uri="{FF2B5EF4-FFF2-40B4-BE49-F238E27FC236}">
+                <a16:creationId xmlns:a16="http://schemas.microsoft.com/office/drawing/2014/main" id="{31CD8128-4DFE-71A1-A0CC-C045FCD55B61}"/>
+              </a:ext>
+            </a:extLst>
+          </p:cNvPr>
+          <p:cNvSpPr txBox="1"/>
+          <p:nvPr/>
+        </p:nvSpPr>
+        <p:spPr>
+          <a:xfrm>
+            <a:off x="800100" y="15506700"/>
+            <a:ext cx="7847020" cy="1077218"/>
+          </a:xfrm>
+          <a:prstGeom prst="rect">
+            <a:avLst/>
+          </a:prstGeom>
+          <a:noFill/>
+        </p:spPr>
+        <p:txBody>
+          <a:bodyPr wrap="none" rtlCol="0">
+            <a:spAutoFit/>
+          </a:bodyPr>
+          <a:lstStyle/>
+          <a:p>
+            <a:r>
+              <a:rPr lang="en-US" sz="6400" dirty="0"/>
+              <a:t>Project Requirements</a:t>
+            </a:r>
+          </a:p>
+        </p:txBody>
+      </p:sp>
+      <p:sp>
+        <p:nvSpPr>
+          <p:cNvPr id="9" name="TextBox 8">
+            <a:extLst>
+              <a:ext uri="{FF2B5EF4-FFF2-40B4-BE49-F238E27FC236}">
+                <a16:creationId xmlns:a16="http://schemas.microsoft.com/office/drawing/2014/main" id="{3EE8103C-E4BE-1BB1-AD3A-4DB3F998EC95}"/>
+              </a:ext>
+            </a:extLst>
+          </p:cNvPr>
+          <p:cNvSpPr txBox="1"/>
+          <p:nvPr/>
+        </p:nvSpPr>
+        <p:spPr>
+          <a:xfrm>
+            <a:off x="22464414" y="4572000"/>
+            <a:ext cx="2624436" cy="1077218"/>
+          </a:xfrm>
+          <a:prstGeom prst="rect">
+            <a:avLst/>
+          </a:prstGeom>
+          <a:noFill/>
+        </p:spPr>
+        <p:txBody>
+          <a:bodyPr wrap="none" rtlCol="0">
+            <a:spAutoFit/>
+          </a:bodyPr>
+          <a:lstStyle/>
+          <a:p>
+            <a:r>
+              <a:rPr lang="en-US" sz="6400" dirty="0"/>
+              <a:t>Design</a:t>
+            </a:r>
+          </a:p>
+        </p:txBody>
+      </p:sp>
+      <p:sp>
+        <p:nvSpPr>
+          <p:cNvPr id="10" name="TextBox 9">
+            <a:extLst>
+              <a:ext uri="{FF2B5EF4-FFF2-40B4-BE49-F238E27FC236}">
+                <a16:creationId xmlns:a16="http://schemas.microsoft.com/office/drawing/2014/main" id="{8B0C8A14-BAF8-6EE3-8A52-1B59464C6252}"/>
+              </a:ext>
+            </a:extLst>
+          </p:cNvPr>
+          <p:cNvSpPr txBox="1"/>
+          <p:nvPr/>
+        </p:nvSpPr>
+        <p:spPr>
+          <a:xfrm>
+            <a:off x="28732049" y="15468600"/>
+            <a:ext cx="2650084" cy="1077218"/>
+          </a:xfrm>
+          <a:prstGeom prst="rect">
+            <a:avLst/>
+          </a:prstGeom>
+          <a:noFill/>
+        </p:spPr>
+        <p:txBody>
+          <a:bodyPr wrap="none" rtlCol="0">
+            <a:spAutoFit/>
+          </a:bodyPr>
+          <a:lstStyle/>
+          <a:p>
+            <a:r>
+              <a:rPr lang="en-US" sz="6400" dirty="0"/>
+              <a:t>Testing</a:t>
+            </a:r>
+          </a:p>
+        </p:txBody>
+      </p:sp>
+      <p:sp>
+        <p:nvSpPr>
+          <p:cNvPr id="11" name="TextBox 10">
+            <a:extLst>
+              <a:ext uri="{FF2B5EF4-FFF2-40B4-BE49-F238E27FC236}">
+                <a16:creationId xmlns:a16="http://schemas.microsoft.com/office/drawing/2014/main" id="{89DE0F53-B039-28EA-B5C8-A24BD4431E1F}"/>
+              </a:ext>
+            </a:extLst>
+          </p:cNvPr>
+          <p:cNvSpPr txBox="1"/>
+          <p:nvPr/>
+        </p:nvSpPr>
+        <p:spPr>
+          <a:xfrm>
+            <a:off x="17391761" y="15506700"/>
+            <a:ext cx="1792478" cy="1077218"/>
+          </a:xfrm>
+          <a:prstGeom prst="rect">
+            <a:avLst/>
+          </a:prstGeom>
+          <a:noFill/>
+        </p:spPr>
+        <p:txBody>
+          <a:bodyPr wrap="none" rtlCol="0">
+            <a:spAutoFit/>
+          </a:bodyPr>
+          <a:lstStyle/>
+          <a:p>
+            <a:r>
+              <a:rPr lang="en-US" sz="6400" dirty="0"/>
+              <a:t>MAP</a:t>
+            </a:r>
+          </a:p>
+        </p:txBody>
+      </p:sp>
+      <p:sp>
+        <p:nvSpPr>
+          <p:cNvPr id="13" name="TextBox 12">
+            <a:extLst>
+              <a:ext uri="{FF2B5EF4-FFF2-40B4-BE49-F238E27FC236}">
+                <a16:creationId xmlns:a16="http://schemas.microsoft.com/office/drawing/2014/main" id="{873A7FF4-2B65-3FAA-DF2E-2D69CAD8EDBD}"/>
+              </a:ext>
+            </a:extLst>
+          </p:cNvPr>
+          <p:cNvSpPr txBox="1"/>
+          <p:nvPr/>
+        </p:nvSpPr>
+        <p:spPr>
+          <a:xfrm>
+            <a:off x="12195575" y="8692515"/>
+            <a:ext cx="5196186" cy="3046988"/>
+          </a:xfrm>
+          <a:prstGeom prst="rect">
+            <a:avLst/>
+          </a:prstGeom>
+          <a:noFill/>
+        </p:spPr>
+        <p:txBody>
+          <a:bodyPr wrap="square" rtlCol="0">
+            <a:spAutoFit/>
+          </a:bodyPr>
+          <a:lstStyle/>
+          <a:p>
+            <a:r>
+              <a:rPr lang="en-US" sz="6400" dirty="0"/>
+              <a:t>HIGH LEVEL DESIGN DIAGRAM</a:t>
+            </a:r>
+          </a:p>
+        </p:txBody>
+      </p:sp>
+      <p:sp>
+        <p:nvSpPr>
+          <p:cNvPr id="14" name="TextBox 13">
+            <a:extLst>
+              <a:ext uri="{FF2B5EF4-FFF2-40B4-BE49-F238E27FC236}">
+                <a16:creationId xmlns:a16="http://schemas.microsoft.com/office/drawing/2014/main" id="{77E6252E-F7C1-B447-456D-104E54C3F395}"/>
+              </a:ext>
+            </a:extLst>
+          </p:cNvPr>
+          <p:cNvSpPr txBox="1"/>
+          <p:nvPr/>
+        </p:nvSpPr>
+        <p:spPr>
+          <a:xfrm>
+            <a:off x="21178539" y="8692515"/>
+            <a:ext cx="5196186" cy="1077218"/>
+          </a:xfrm>
+          <a:prstGeom prst="rect">
+            <a:avLst/>
+          </a:prstGeom>
+          <a:noFill/>
+        </p:spPr>
+        <p:txBody>
+          <a:bodyPr wrap="square" rtlCol="0">
+            <a:spAutoFit/>
+          </a:bodyPr>
+          <a:lstStyle/>
+          <a:p>
+            <a:r>
+              <a:rPr lang="en-US" sz="6400" dirty="0"/>
+              <a:t>TWINE STORY</a:t>
+            </a:r>
+          </a:p>
+        </p:txBody>
+      </p:sp>
+      <p:sp>
+        <p:nvSpPr>
+          <p:cNvPr id="15" name="TextBox 14">
+            <a:extLst>
+              <a:ext uri="{FF2B5EF4-FFF2-40B4-BE49-F238E27FC236}">
+                <a16:creationId xmlns:a16="http://schemas.microsoft.com/office/drawing/2014/main" id="{80E123D4-5499-DAD5-9A1A-705429796B50}"/>
+              </a:ext>
+            </a:extLst>
+          </p:cNvPr>
+          <p:cNvSpPr txBox="1"/>
+          <p:nvPr/>
+        </p:nvSpPr>
+        <p:spPr>
+          <a:xfrm>
+            <a:off x="30057091" y="8692515"/>
+            <a:ext cx="5196186" cy="2062103"/>
+          </a:xfrm>
+          <a:prstGeom prst="rect">
+            <a:avLst/>
+          </a:prstGeom>
+          <a:noFill/>
+        </p:spPr>
+        <p:txBody>
+          <a:bodyPr wrap="square" rtlCol="0">
+            <a:spAutoFit/>
+          </a:bodyPr>
+          <a:lstStyle/>
+          <a:p>
+            <a:r>
+              <a:rPr lang="en-US" sz="6400" dirty="0"/>
+              <a:t>WEBAPP PAGE</a:t>
+            </a:r>
           </a:p>
         </p:txBody>
       </p:sp>

</xml_diff>

<commit_message>
Finished draft of poster
</commit_message>
<xml_diff>
--- a/Poster/CSC SDC Poster.pptx
+++ b/Poster/CSC SDC Poster.pptx
@@ -274,7 +274,7 @@
           <a:p>
             <a:fld id="{FE9B830F-8D59-4B23-9C61-1E12B66C3D45}" type="datetimeFigureOut">
               <a:rPr lang="en-US" smtClean="0"/>
-              <a:t>3/27/2026</a:t>
+              <a:t>3/29/2026</a:t>
             </a:fld>
             <a:endParaRPr lang="en-US"/>
           </a:p>
@@ -444,7 +444,7 @@
           <a:p>
             <a:fld id="{FE9B830F-8D59-4B23-9C61-1E12B66C3D45}" type="datetimeFigureOut">
               <a:rPr lang="en-US" smtClean="0"/>
-              <a:t>3/27/2026</a:t>
+              <a:t>3/29/2026</a:t>
             </a:fld>
             <a:endParaRPr lang="en-US"/>
           </a:p>
@@ -624,7 +624,7 @@
           <a:p>
             <a:fld id="{FE9B830F-8D59-4B23-9C61-1E12B66C3D45}" type="datetimeFigureOut">
               <a:rPr lang="en-US" smtClean="0"/>
-              <a:t>3/27/2026</a:t>
+              <a:t>3/29/2026</a:t>
             </a:fld>
             <a:endParaRPr lang="en-US"/>
           </a:p>
@@ -794,7 +794,7 @@
           <a:p>
             <a:fld id="{FE9B830F-8D59-4B23-9C61-1E12B66C3D45}" type="datetimeFigureOut">
               <a:rPr lang="en-US" smtClean="0"/>
-              <a:t>3/27/2026</a:t>
+              <a:t>3/29/2026</a:t>
             </a:fld>
             <a:endParaRPr lang="en-US"/>
           </a:p>
@@ -1040,7 +1040,7 @@
           <a:p>
             <a:fld id="{FE9B830F-8D59-4B23-9C61-1E12B66C3D45}" type="datetimeFigureOut">
               <a:rPr lang="en-US" smtClean="0"/>
-              <a:t>3/27/2026</a:t>
+              <a:t>3/29/2026</a:t>
             </a:fld>
             <a:endParaRPr lang="en-US"/>
           </a:p>
@@ -1272,7 +1272,7 @@
           <a:p>
             <a:fld id="{FE9B830F-8D59-4B23-9C61-1E12B66C3D45}" type="datetimeFigureOut">
               <a:rPr lang="en-US" smtClean="0"/>
-              <a:t>3/27/2026</a:t>
+              <a:t>3/29/2026</a:t>
             </a:fld>
             <a:endParaRPr lang="en-US"/>
           </a:p>
@@ -1639,7 +1639,7 @@
           <a:p>
             <a:fld id="{FE9B830F-8D59-4B23-9C61-1E12B66C3D45}" type="datetimeFigureOut">
               <a:rPr lang="en-US" smtClean="0"/>
-              <a:t>3/27/2026</a:t>
+              <a:t>3/29/2026</a:t>
             </a:fld>
             <a:endParaRPr lang="en-US"/>
           </a:p>
@@ -1757,7 +1757,7 @@
           <a:p>
             <a:fld id="{FE9B830F-8D59-4B23-9C61-1E12B66C3D45}" type="datetimeFigureOut">
               <a:rPr lang="en-US" smtClean="0"/>
-              <a:t>3/27/2026</a:t>
+              <a:t>3/29/2026</a:t>
             </a:fld>
             <a:endParaRPr lang="en-US"/>
           </a:p>
@@ -1852,7 +1852,7 @@
           <a:p>
             <a:fld id="{FE9B830F-8D59-4B23-9C61-1E12B66C3D45}" type="datetimeFigureOut">
               <a:rPr lang="en-US" smtClean="0"/>
-              <a:t>3/27/2026</a:t>
+              <a:t>3/29/2026</a:t>
             </a:fld>
             <a:endParaRPr lang="en-US"/>
           </a:p>
@@ -2129,7 +2129,7 @@
           <a:p>
             <a:fld id="{FE9B830F-8D59-4B23-9C61-1E12B66C3D45}" type="datetimeFigureOut">
               <a:rPr lang="en-US" smtClean="0"/>
-              <a:t>3/27/2026</a:t>
+              <a:t>3/29/2026</a:t>
             </a:fld>
             <a:endParaRPr lang="en-US"/>
           </a:p>
@@ -2386,7 +2386,7 @@
           <a:p>
             <a:fld id="{FE9B830F-8D59-4B23-9C61-1E12B66C3D45}" type="datetimeFigureOut">
               <a:rPr lang="en-US" smtClean="0"/>
-              <a:t>3/27/2026</a:t>
+              <a:t>3/29/2026</a:t>
             </a:fld>
             <a:endParaRPr lang="en-US"/>
           </a:p>
@@ -2599,7 +2599,7 @@
           <a:p>
             <a:fld id="{FE9B830F-8D59-4B23-9C61-1E12B66C3D45}" type="datetimeFigureOut">
               <a:rPr lang="en-US" smtClean="0"/>
-              <a:t>3/27/2026</a:t>
+              <a:t>3/29/2026</a:t>
             </a:fld>
             <a:endParaRPr lang="en-US"/>
           </a:p>
@@ -3054,10 +3054,10 @@
           <p:nvPr/>
         </p:nvPicPr>
         <p:blipFill>
-          <a:blip r:embed="rId2">
+          <a:blip>
             <a:extLst>
               <a:ext uri="{96DAC541-7B7A-43D3-8B79-37D633B846F1}">
-                <asvg:svgBlip xmlns:asvg="http://schemas.microsoft.com/office/drawing/2016/SVG/main" r:embed="rId3"/>
+                <asvg:svgBlip xmlns:asvg="http://schemas.microsoft.com/office/drawing/2016/SVG/main" r:embed="rId2"/>
               </a:ext>
             </a:extLst>
           </a:blip>
@@ -3199,8 +3199,8 @@
         </p:nvSpPr>
         <p:spPr>
           <a:xfrm>
-            <a:off x="606424" y="3564209"/>
-            <a:ext cx="7544822" cy="1077218"/>
+            <a:off x="1426289" y="3564209"/>
+            <a:ext cx="6616299" cy="1077218"/>
           </a:xfrm>
           <a:prstGeom prst="rect">
             <a:avLst/>
@@ -3216,7 +3216,7 @@
             <a:pPr algn="ctr"/>
             <a:r>
               <a:rPr lang="en-US" sz="6400" dirty="0"/>
-              <a:t>Sponsor Background</a:t>
+              <a:t>Problem Overview</a:t>
             </a:r>
           </a:p>
         </p:txBody>
@@ -3235,7 +3235,7 @@
         </p:nvSpPr>
         <p:spPr>
           <a:xfrm>
-            <a:off x="1906841" y="10074063"/>
+            <a:off x="2262439" y="10712844"/>
             <a:ext cx="5171609" cy="1077218"/>
           </a:xfrm>
           <a:prstGeom prst="rect">
@@ -3295,42 +3295,6 @@
       </p:sp>
       <p:sp>
         <p:nvSpPr>
-          <p:cNvPr id="11" name="TextBox 10">
-            <a:extLst>
-              <a:ext uri="{FF2B5EF4-FFF2-40B4-BE49-F238E27FC236}">
-                <a16:creationId xmlns:a16="http://schemas.microsoft.com/office/drawing/2014/main" id="{89DE0F53-B039-28EA-B5C8-A24BD4431E1F}"/>
-              </a:ext>
-            </a:extLst>
-          </p:cNvPr>
-          <p:cNvSpPr txBox="1"/>
-          <p:nvPr/>
-        </p:nvSpPr>
-        <p:spPr>
-          <a:xfrm>
-            <a:off x="31009023" y="3564209"/>
-            <a:ext cx="1792478" cy="1077218"/>
-          </a:xfrm>
-          <a:prstGeom prst="rect">
-            <a:avLst/>
-          </a:prstGeom>
-          <a:noFill/>
-        </p:spPr>
-        <p:txBody>
-          <a:bodyPr wrap="none" rtlCol="0">
-            <a:spAutoFit/>
-          </a:bodyPr>
-          <a:lstStyle/>
-          <a:p>
-            <a:pPr algn="ctr"/>
-            <a:r>
-              <a:rPr lang="en-US" sz="6400" dirty="0"/>
-              <a:t>MAP</a:t>
-            </a:r>
-          </a:p>
-        </p:txBody>
-      </p:sp>
-      <p:sp>
-        <p:nvSpPr>
           <p:cNvPr id="13" name="TextBox 12">
             <a:extLst>
               <a:ext uri="{FF2B5EF4-FFF2-40B4-BE49-F238E27FC236}">
@@ -3343,7 +3307,7 @@
         </p:nvSpPr>
         <p:spPr>
           <a:xfrm>
-            <a:off x="14133996" y="3564209"/>
+            <a:off x="18442955" y="3582478"/>
             <a:ext cx="8308008" cy="1077218"/>
           </a:xfrm>
           <a:prstGeom prst="rect">
@@ -3407,6 +3371,84 @@
             <a:extLst>
               <a:ext uri="{FF2B5EF4-FFF2-40B4-BE49-F238E27FC236}">
                 <a16:creationId xmlns:a16="http://schemas.microsoft.com/office/drawing/2014/main" id="{1D76B6A1-0ED9-0027-0C95-CAE2B2486598}"/>
+              </a:ext>
+            </a:extLst>
+          </p:cNvPr>
+          <p:cNvPicPr>
+            <a:picLocks noChangeAspect="1"/>
+          </p:cNvPicPr>
+          <p:nvPr/>
+        </p:nvPicPr>
+        <p:blipFill>
+          <a:blip r:embed="rId3">
+            <a:extLst>
+              <a:ext uri="{28A0092B-C50C-407E-A947-70E740481C1C}">
+                <a14:useLocalDpi xmlns:a14="http://schemas.microsoft.com/office/drawing/2010/main" val="0"/>
+              </a:ext>
+            </a:extLst>
+          </a:blip>
+          <a:srcRect l="3442" b="5427"/>
+          <a:stretch>
+            <a:fillRect/>
+          </a:stretch>
+        </p:blipFill>
+        <p:spPr>
+          <a:xfrm>
+            <a:off x="14133996" y="4550030"/>
+            <a:ext cx="17931814" cy="12325627"/>
+          </a:xfrm>
+          <a:prstGeom prst="rect">
+            <a:avLst/>
+          </a:prstGeom>
+          <a:ln>
+            <a:solidFill>
+              <a:schemeClr val="tx1"/>
+            </a:solidFill>
+          </a:ln>
+        </p:spPr>
+      </p:pic>
+      <p:sp>
+        <p:nvSpPr>
+          <p:cNvPr id="16" name="TextBox 15">
+            <a:extLst>
+              <a:ext uri="{FF2B5EF4-FFF2-40B4-BE49-F238E27FC236}">
+                <a16:creationId xmlns:a16="http://schemas.microsoft.com/office/drawing/2014/main" id="{B79A54E9-61D7-71A1-794E-F7FF1CF2E0C6}"/>
+              </a:ext>
+            </a:extLst>
+          </p:cNvPr>
+          <p:cNvSpPr txBox="1"/>
+          <p:nvPr/>
+        </p:nvSpPr>
+        <p:spPr>
+          <a:xfrm>
+            <a:off x="1966911" y="17146888"/>
+            <a:ext cx="5762668" cy="1077218"/>
+          </a:xfrm>
+          <a:prstGeom prst="rect">
+            <a:avLst/>
+          </a:prstGeom>
+          <a:noFill/>
+        </p:spPr>
+        <p:txBody>
+          <a:bodyPr wrap="none" rtlCol="0">
+            <a:spAutoFit/>
+          </a:bodyPr>
+          <a:lstStyle/>
+          <a:p>
+            <a:pPr algn="ctr"/>
+            <a:r>
+              <a:rPr lang="en-US" sz="6400" dirty="0"/>
+              <a:t>Gameplay Loop</a:t>
+            </a:r>
+          </a:p>
+        </p:txBody>
+      </p:sp>
+      <p:pic>
+        <p:nvPicPr>
+          <p:cNvPr id="18" name="Picture 17">
+            <a:extLst>
+              <a:ext uri="{FF2B5EF4-FFF2-40B4-BE49-F238E27FC236}">
+                <a16:creationId xmlns:a16="http://schemas.microsoft.com/office/drawing/2014/main" id="{3E1259C9-8F12-5999-B4D6-48ECE7439691}"/>
               </a:ext>
             </a:extLst>
           </p:cNvPr>
@@ -3423,32 +3465,26 @@
               </a:ext>
             </a:extLst>
           </a:blip>
-          <a:srcRect l="3442" b="5427"/>
           <a:stretch>
             <a:fillRect/>
           </a:stretch>
         </p:blipFill>
         <p:spPr>
           <a:xfrm>
-            <a:off x="9322093" y="4731344"/>
-            <a:ext cx="17931814" cy="12325627"/>
+            <a:off x="10172699" y="18951928"/>
+            <a:ext cx="17081207" cy="7136510"/>
           </a:xfrm>
           <a:prstGeom prst="rect">
             <a:avLst/>
           </a:prstGeom>
-          <a:ln>
-            <a:solidFill>
-              <a:schemeClr val="tx1"/>
-            </a:solidFill>
-          </a:ln>
         </p:spPr>
       </p:pic>
       <p:sp>
         <p:nvSpPr>
-          <p:cNvPr id="16" name="TextBox 15">
+          <p:cNvPr id="7" name="TextBox 6">
             <a:extLst>
               <a:ext uri="{FF2B5EF4-FFF2-40B4-BE49-F238E27FC236}">
-                <a16:creationId xmlns:a16="http://schemas.microsoft.com/office/drawing/2014/main" id="{B79A54E9-61D7-71A1-794E-F7FF1CF2E0C6}"/>
+                <a16:creationId xmlns:a16="http://schemas.microsoft.com/office/drawing/2014/main" id="{FE4E5154-08E0-A303-22F9-77385AB60EFA}"/>
               </a:ext>
             </a:extLst>
           </p:cNvPr>
@@ -3457,8 +3493,8 @@
         </p:nvSpPr>
         <p:spPr>
           <a:xfrm>
-            <a:off x="2020654" y="17146888"/>
-            <a:ext cx="4943982" cy="1077218"/>
+            <a:off x="549298" y="4641427"/>
+            <a:ext cx="8597893" cy="5670078"/>
           </a:xfrm>
           <a:prstGeom prst="rect">
             <a:avLst/>
@@ -3466,55 +3502,242 @@
           <a:noFill/>
         </p:spPr>
         <p:txBody>
-          <a:bodyPr wrap="none" rtlCol="0">
+          <a:bodyPr wrap="square" rtlCol="0">
             <a:spAutoFit/>
           </a:bodyPr>
           <a:lstStyle/>
           <a:p>
-            <a:pPr algn="ctr"/>
-            <a:r>
-              <a:rPr lang="en-US" sz="6400" dirty="0"/>
-              <a:t>Project Goals</a:t>
-            </a:r>
-          </a:p>
-        </p:txBody>
-      </p:sp>
-      <p:pic>
-        <p:nvPicPr>
-          <p:cNvPr id="18" name="Picture 17">
+            <a:pPr marL="857250" indent="-857250">
+              <a:lnSpc>
+                <a:spcPct val="150000"/>
+              </a:lnSpc>
+              <a:buFont typeface="Arial" panose="020B0604020202020204" pitchFamily="34" charset="0"/>
+              <a:buChar char="•"/>
+            </a:pPr>
+            <a:r>
+              <a:rPr lang="en-US" sz="3500" b="1" dirty="0"/>
+              <a:t>Sponsor: </a:t>
+            </a:r>
+            <a:r>
+              <a:rPr lang="en-US" sz="3500" dirty="0"/>
+              <a:t>Dr Renee Harrington, Department of Health and Exercise Studies at NCSU</a:t>
+            </a:r>
+            <a:endParaRPr lang="en-US" sz="3500" b="1" dirty="0"/>
+          </a:p>
+          <a:p>
+            <a:pPr marL="857250" indent="-857250">
+              <a:lnSpc>
+                <a:spcPct val="150000"/>
+              </a:lnSpc>
+              <a:buFont typeface="Arial" panose="020B0604020202020204" pitchFamily="34" charset="0"/>
+              <a:buChar char="•"/>
+            </a:pPr>
+            <a:r>
+              <a:rPr lang="en-US" sz="3500" b="1" dirty="0"/>
+              <a:t>Problem: </a:t>
+            </a:r>
+            <a:r>
+              <a:rPr lang="en-US" sz="3500" dirty="0"/>
+              <a:t>Existing nutritional education is unengaging and unrelatable</a:t>
+            </a:r>
+            <a:endParaRPr lang="en-US" sz="3500" b="1" dirty="0"/>
+          </a:p>
+          <a:p>
+            <a:pPr marL="857250" indent="-857250">
+              <a:lnSpc>
+                <a:spcPct val="150000"/>
+              </a:lnSpc>
+              <a:buFont typeface="Arial" panose="020B0604020202020204" pitchFamily="34" charset="0"/>
+              <a:buChar char="•"/>
+            </a:pPr>
+            <a:r>
+              <a:rPr lang="en-US" sz="3500" b="1" dirty="0"/>
+              <a:t>Goal: </a:t>
+            </a:r>
+            <a:r>
+              <a:rPr lang="en-US" sz="3500" dirty="0"/>
+              <a:t>Create an educational game that fun and relevant to students</a:t>
+            </a:r>
+            <a:endParaRPr lang="en-US" sz="3500" b="1" dirty="0"/>
+          </a:p>
+        </p:txBody>
+      </p:sp>
+      <p:sp>
+        <p:nvSpPr>
+          <p:cNvPr id="9" name="TextBox 8">
             <a:extLst>
               <a:ext uri="{FF2B5EF4-FFF2-40B4-BE49-F238E27FC236}">
-                <a16:creationId xmlns:a16="http://schemas.microsoft.com/office/drawing/2014/main" id="{3E1259C9-8F12-5999-B4D6-48ECE7439691}"/>
+                <a16:creationId xmlns:a16="http://schemas.microsoft.com/office/drawing/2014/main" id="{85EF382E-C24D-C0E4-F546-61E516B25931}"/>
               </a:ext>
             </a:extLst>
           </p:cNvPr>
-          <p:cNvPicPr>
-            <a:picLocks noChangeAspect="1"/>
-          </p:cNvPicPr>
+          <p:cNvSpPr txBox="1"/>
           <p:nvPr/>
-        </p:nvPicPr>
-        <p:blipFill>
-          <a:blip r:embed="rId5">
-            <a:extLst>
-              <a:ext uri="{28A0092B-C50C-407E-A947-70E740481C1C}">
-                <a14:useLocalDpi xmlns:a14="http://schemas.microsoft.com/office/drawing/2010/main" val="0"/>
-              </a:ext>
-            </a:extLst>
-          </a:blip>
-          <a:stretch>
-            <a:fillRect/>
-          </a:stretch>
-        </p:blipFill>
+        </p:nvSpPr>
         <p:spPr>
           <a:xfrm>
-            <a:off x="9322093" y="18596545"/>
-            <a:ext cx="17931814" cy="7491893"/>
+            <a:off x="549298" y="11790062"/>
+            <a:ext cx="8778852" cy="4862165"/>
           </a:xfrm>
           <a:prstGeom prst="rect">
             <a:avLst/>
           </a:prstGeom>
+          <a:noFill/>
         </p:spPr>
-      </p:pic>
+        <p:txBody>
+          <a:bodyPr wrap="square" rtlCol="0">
+            <a:spAutoFit/>
+          </a:bodyPr>
+          <a:lstStyle/>
+          <a:p>
+            <a:pPr marL="857250" indent="-857250">
+              <a:lnSpc>
+                <a:spcPct val="150000"/>
+              </a:lnSpc>
+              <a:buFont typeface="Arial" panose="020B0604020202020204" pitchFamily="34" charset="0"/>
+              <a:buChar char="•"/>
+            </a:pPr>
+            <a:r>
+              <a:rPr lang="en-US" sz="3500" b="1" dirty="0"/>
+              <a:t>Game: </a:t>
+            </a:r>
+            <a:r>
+              <a:rPr lang="en-US" sz="3500" dirty="0"/>
+              <a:t>Browser-based interactive CYOA game for on-campus dining options</a:t>
+            </a:r>
+            <a:endParaRPr lang="en-US" sz="3500" b="1" dirty="0"/>
+          </a:p>
+          <a:p>
+            <a:pPr marL="857250" indent="-857250">
+              <a:lnSpc>
+                <a:spcPct val="150000"/>
+              </a:lnSpc>
+              <a:buFont typeface="Arial" panose="020B0604020202020204" pitchFamily="34" charset="0"/>
+              <a:buChar char="•"/>
+            </a:pPr>
+            <a:r>
+              <a:rPr lang="en-US" sz="3500" b="1" dirty="0"/>
+              <a:t>Dashboard: </a:t>
+            </a:r>
+            <a:r>
+              <a:rPr lang="en-US" sz="3500" dirty="0"/>
+              <a:t>Basic web-app for instructors to track student progress</a:t>
+            </a:r>
+            <a:endParaRPr lang="en-US" sz="3500" b="1" dirty="0"/>
+          </a:p>
+          <a:p>
+            <a:pPr marL="857250" indent="-857250">
+              <a:lnSpc>
+                <a:spcPct val="150000"/>
+              </a:lnSpc>
+              <a:buFont typeface="Arial" panose="020B0604020202020204" pitchFamily="34" charset="0"/>
+              <a:buChar char="•"/>
+            </a:pPr>
+            <a:r>
+              <a:rPr lang="en-US" sz="3500" b="1" dirty="0"/>
+              <a:t>Security: </a:t>
+            </a:r>
+            <a:r>
+              <a:rPr lang="en-US" sz="3500" dirty="0"/>
+              <a:t>Integrate Shibboleth authentication for student privacy</a:t>
+            </a:r>
+            <a:endParaRPr lang="en-US" sz="3500" b="1" dirty="0"/>
+          </a:p>
+        </p:txBody>
+      </p:sp>
+      <p:sp>
+        <p:nvSpPr>
+          <p:cNvPr id="17" name="TextBox 16">
+            <a:extLst>
+              <a:ext uri="{FF2B5EF4-FFF2-40B4-BE49-F238E27FC236}">
+                <a16:creationId xmlns:a16="http://schemas.microsoft.com/office/drawing/2014/main" id="{EF12010E-D332-3306-6578-44123484D488}"/>
+              </a:ext>
+            </a:extLst>
+          </p:cNvPr>
+          <p:cNvSpPr txBox="1"/>
+          <p:nvPr/>
+        </p:nvSpPr>
+        <p:spPr>
+          <a:xfrm>
+            <a:off x="28847625" y="20766782"/>
+            <a:ext cx="6436377" cy="2062103"/>
+          </a:xfrm>
+          <a:prstGeom prst="rect">
+            <a:avLst/>
+          </a:prstGeom>
+          <a:noFill/>
+        </p:spPr>
+        <p:txBody>
+          <a:bodyPr wrap="none" rtlCol="0">
+            <a:spAutoFit/>
+          </a:bodyPr>
+          <a:lstStyle/>
+          <a:p>
+            <a:pPr algn="ctr"/>
+            <a:r>
+              <a:rPr lang="en-US" sz="6400" dirty="0"/>
+              <a:t>PUT TEST </a:t>
+            </a:r>
+          </a:p>
+          <a:p>
+            <a:pPr algn="ctr"/>
+            <a:r>
+              <a:rPr lang="en-US" sz="6400" dirty="0"/>
+              <a:t>COVERAGE HERE</a:t>
+            </a:r>
+          </a:p>
+        </p:txBody>
+      </p:sp>
+      <p:sp>
+        <p:nvSpPr>
+          <p:cNvPr id="19" name="TextBox 18">
+            <a:extLst>
+              <a:ext uri="{FF2B5EF4-FFF2-40B4-BE49-F238E27FC236}">
+                <a16:creationId xmlns:a16="http://schemas.microsoft.com/office/drawing/2014/main" id="{7F6F5602-630D-9DC3-DF1A-B8EAB0D48D4E}"/>
+              </a:ext>
+            </a:extLst>
+          </p:cNvPr>
+          <p:cNvSpPr txBox="1"/>
+          <p:nvPr/>
+        </p:nvSpPr>
+        <p:spPr>
+          <a:xfrm>
+            <a:off x="600741" y="21229347"/>
+            <a:ext cx="8495018" cy="3046988"/>
+          </a:xfrm>
+          <a:prstGeom prst="rect">
+            <a:avLst/>
+          </a:prstGeom>
+          <a:noFill/>
+        </p:spPr>
+        <p:txBody>
+          <a:bodyPr wrap="none" rtlCol="0">
+            <a:spAutoFit/>
+          </a:bodyPr>
+          <a:lstStyle/>
+          <a:p>
+            <a:pPr algn="ctr"/>
+            <a:r>
+              <a:rPr lang="en-US" sz="6400" dirty="0"/>
+              <a:t>INSERT GRAPHIC HERE</a:t>
+            </a:r>
+          </a:p>
+          <a:p>
+            <a:pPr algn="ctr"/>
+            <a:r>
+              <a:rPr lang="en-US" sz="6400" dirty="0"/>
+              <a:t>(CHANGE IMAGE IN </a:t>
+            </a:r>
+          </a:p>
+          <a:p>
+            <a:pPr algn="ctr"/>
+            <a:r>
+              <a:rPr lang="en-US" sz="6400" dirty="0"/>
+              <a:t>OPR2 TO SVG)</a:t>
+            </a:r>
+          </a:p>
+        </p:txBody>
+      </p:sp>
     </p:spTree>
     <p:extLst>
       <p:ext uri="{BB962C8B-B14F-4D97-AF65-F5344CB8AC3E}">

</xml_diff>